<commit_message>
fix(app + slide 8): harden secrets fallback, clarify file-count scope
</commit_message>
<xml_diff>
--- a/Phase3_Slides.pptx
+++ b/Phase3_Slides.pptx
@@ -7648,7 +7648,7 @@
                 </a:solidFill>
                 <a:latin typeface="JetBrains Mono"/>
               </a:rPr>
-              <a:t>repo</a:t>
+              <a:t>ph 2</a:t>
             </a:r>
           </a:p>
         </p:txBody>
@@ -7687,7 +7687,7 @@
                 </a:solidFill>
                 <a:latin typeface="JetBrains Mono"/>
               </a:rPr>
-              <a:t>22 files  ·  9 .py + 9 .md + 2 .json + 1 .ipynb + 1 .txt</a:t>
+              <a:t>22 deliverables  ·  9 .py + 9 .md + 2 .json + 1 .ipynb + 1 .txt</a:t>
             </a:r>
           </a:p>
         </p:txBody>

</xml_diff>